<commit_message>
Add evidence/measurement slide (deck now 18) + PD/consulting variant
Admin deck: insert a "Measuring impact" slide (leading indicators the platform
already captures + outcome targets to prove against them) as slide 16.

New PD/consulting deck (10 slides): a business-forward variant positioning
AndersonLogic AI for paid PD/consulting — the Augment Method (named portable
framework), "what your teachers will be able to do," a transferability example,
credibility, and an offer + CTA. Placeholders marked for framework name,
credentials, pricing, and business contact.

Co-Authored-By: Claude Opus 4.8 <noreply@anthropic.com>
Claude-Session: https://claude.ai/code/session_013AeDbUibQywf8Yx3P1EQzF
</commit_message>
<xml_diff>
--- a/pitch/BeHistorical-AndersonLogic-AI.pptx
+++ b/pitch/BeHistorical-AndersonLogic-AI.pptx
@@ -22,9 +22,10 @@
     <p:sldId id="270" r:id="rId16"/>
     <p:sldId id="271" r:id="rId17"/>
     <p:sldId id="272" r:id="rId18"/>
+    <p:sldId id="273" r:id="rId19"/>
   </p:sldIdLst>
   <p:notesMasterIdLst>
-    <p:notesMasterId r:id="rId19"/>
+    <p:notesMasterId r:id="rId20"/>
   </p:notesMasterIdLst>
   <p:sldSz cx="12192000" cy="6858000"/>
   <p:notesSz cx="6858000" cy="12192000"/>
@@ -1246,6 +1247,94 @@
             <a:fld id="{F7021451-1387-4CA6-816F-3879F97B5CBC}" type="slidenum">
               <a:rPr lang="en-US"/>
               <a:t>17</a:t>
+            </a:fld>
+            <a:endParaRPr lang="en-US"/>
+          </a:p>
+        </p:txBody>
+      </p:sp>
+    </p:spTree>
+    <p:extLst>
+      <p:ext uri="{BB962C8B-B14F-4D97-AF65-F5344CB8AC3E}">
+        <p14:creationId xmlns:p14="http://schemas.microsoft.com/office/powerpoint/2010/main" val="1024086991"/>
+      </p:ext>
+    </p:extLst>
+  </p:cSld>
+  <p:clrMapOvr>
+    <a:masterClrMapping/>
+  </p:clrMapOvr>
+</p:notes>
+</file>
+
+<file path=ppt/notesSlides/notesSlide18.xml><?xml version="1.0" encoding="utf-8"?>
+<p:notes xmlns:a="http://schemas.openxmlformats.org/drawingml/2006/main" xmlns:r="http://schemas.openxmlformats.org/officeDocument/2006/relationships" xmlns:p="http://schemas.openxmlformats.org/presentationml/2006/main">
+  <p:cSld>
+    <p:spTree>
+      <p:nvGrpSpPr>
+        <p:cNvPr id="1" name=""/>
+        <p:cNvGrpSpPr/>
+        <p:nvPr/>
+      </p:nvGrpSpPr>
+      <p:grpSpPr>
+        <a:xfrm>
+          <a:off x="0" y="0"/>
+          <a:ext cx="0" cy="0"/>
+          <a:chOff x="0" y="0"/>
+          <a:chExt cx="0" cy="0"/>
+        </a:xfrm>
+      </p:grpSpPr>
+      <p:sp>
+        <p:nvSpPr>
+          <p:cNvPr id="2" name="Slide Image Placeholder 1"/>
+          <p:cNvSpPr>
+            <a:spLocks noGrp="1" noRot="1" noChangeAspect="1"/>
+          </p:cNvSpPr>
+          <p:nvPr>
+            <p:ph type="sldImg"/>
+          </p:nvPr>
+        </p:nvSpPr>
+        <p:spPr/>
+      </p:sp>
+      <p:sp>
+        <p:nvSpPr>
+          <p:cNvPr id="3" name="Notes Placeholder 2"/>
+          <p:cNvSpPr>
+            <a:spLocks noGrp="1"/>
+          </p:cNvSpPr>
+          <p:nvPr>
+            <p:ph type="body" idx="1"/>
+          </p:nvPr>
+        </p:nvSpPr>
+        <p:spPr/>
+        <p:txBody>
+          <a:bodyPr/>
+          <a:lstStyle/>
+          <a:p>
+            <a:r>
+              <a:rPr lang="en-US" dirty="0"/>
+              <a:t/>
+            </a:r>
+            <a:endParaRPr lang="en-US" dirty="0"/>
+          </a:p>
+        </p:txBody>
+      </p:sp>
+      <p:sp>
+        <p:nvSpPr>
+          <p:cNvPr id="4" name="Slide Number Placeholder 3"/>
+          <p:cNvSpPr>
+            <a:spLocks noGrp="1"/>
+          </p:cNvSpPr>
+          <p:nvPr>
+            <p:ph type="sldNum" sz="quarter" idx="10"/>
+          </p:nvPr>
+        </p:nvSpPr>
+        <p:spPr/>
+        <p:txBody>
+          <a:bodyPr/>
+          <a:lstStyle/>
+          <a:p>
+            <a:fld id="{F7021451-1387-4CA6-816F-3879F97B5CBC}" type="slidenum">
+              <a:rPr lang="en-US"/>
+              <a:t>18</a:t>
             </a:fld>
             <a:endParaRPr lang="en-US"/>
           </a:p>
@@ -2614,7 +2703,7 @@
                 <a:ea typeface="Consolas" pitchFamily="34" charset="-122"/>
                 <a:cs typeface="Consolas" pitchFamily="34" charset="-120"/>
               </a:rPr>
-              <a:t>01 / 17</a:t>
+              <a:t>01 / 18</a:t>
             </a:r>
             <a:endParaRPr lang="en-US" sz="1100" dirty="0"/>
           </a:p>
@@ -3410,7 +3499,7 @@
                 <a:ea typeface="Consolas" pitchFamily="34" charset="-122"/>
                 <a:cs typeface="Consolas" pitchFamily="34" charset="-120"/>
               </a:rPr>
-              <a:t>10 / 17</a:t>
+              <a:t>10 / 18</a:t>
             </a:r>
             <a:endParaRPr lang="en-US" sz="1100" dirty="0"/>
           </a:p>
@@ -4299,7 +4388,7 @@
                 <a:ea typeface="Consolas" pitchFamily="34" charset="-122"/>
                 <a:cs typeface="Consolas" pitchFamily="34" charset="-120"/>
               </a:rPr>
-              <a:t>11 / 17</a:t>
+              <a:t>11 / 18</a:t>
             </a:r>
             <a:endParaRPr lang="en-US" sz="1100" dirty="0"/>
           </a:p>
@@ -4960,7 +5049,7 @@
                 <a:ea typeface="Consolas" pitchFamily="34" charset="-122"/>
                 <a:cs typeface="Consolas" pitchFamily="34" charset="-120"/>
               </a:rPr>
-              <a:t>12 / 17</a:t>
+              <a:t>12 / 18</a:t>
             </a:r>
             <a:endParaRPr lang="en-US" sz="1100" dirty="0"/>
           </a:p>
@@ -5777,7 +5866,7 @@
                 <a:ea typeface="Consolas" pitchFamily="34" charset="-122"/>
                 <a:cs typeface="Consolas" pitchFamily="34" charset="-120"/>
               </a:rPr>
-              <a:t>13 / 17</a:t>
+              <a:t>13 / 18</a:t>
             </a:r>
             <a:endParaRPr lang="en-US" sz="1100" dirty="0"/>
           </a:p>
@@ -6468,7 +6557,7 @@
                 <a:ea typeface="Consolas" pitchFamily="34" charset="-122"/>
                 <a:cs typeface="Consolas" pitchFamily="34" charset="-120"/>
               </a:rPr>
-              <a:t>14 / 17</a:t>
+              <a:t>14 / 18</a:t>
             </a:r>
             <a:endParaRPr lang="en-US" sz="1100" dirty="0"/>
           </a:p>
@@ -7390,7 +7479,7 @@
                 <a:ea typeface="Consolas" pitchFamily="34" charset="-122"/>
                 <a:cs typeface="Consolas" pitchFamily="34" charset="-120"/>
               </a:rPr>
-              <a:t>15 / 17</a:t>
+              <a:t>15 / 18</a:t>
             </a:r>
             <a:endParaRPr lang="en-US" sz="1100" dirty="0"/>
           </a:p>
@@ -8616,7 +8705,7 @@
                 <a:ea typeface="Consolas" pitchFamily="34" charset="-122"/>
                 <a:cs typeface="Consolas" pitchFamily="34" charset="-120"/>
               </a:rPr>
-              <a:t>16 / 17</a:t>
+              <a:t>17 / 18</a:t>
             </a:r>
             <a:endParaRPr lang="en-US" sz="1100" dirty="0"/>
           </a:p>
@@ -8633,6 +8722,630 @@
 <file path=ppt/slides/slide17.xml><?xml version="1.0" encoding="utf-8"?>
 <p:sld xmlns:a="http://schemas.openxmlformats.org/drawingml/2006/main" xmlns:r="http://schemas.openxmlformats.org/officeDocument/2006/relationships" xmlns:p="http://schemas.openxmlformats.org/presentationml/2006/main">
   <p:cSld name="Slide 17">
+    <p:bg>
+      <p:bgPr>
+        <a:solidFill>
+          <a:srgbClr val="F4EEE2"/>
+        </a:solidFill>
+      </p:bgPr>
+    </p:bg>
+    <p:spTree>
+      <p:nvGrpSpPr>
+        <p:cNvPr id="1" name=""/>
+        <p:cNvGrpSpPr/>
+        <p:nvPr/>
+      </p:nvGrpSpPr>
+      <p:grpSpPr>
+        <a:xfrm>
+          <a:off x="0" y="0"/>
+          <a:ext cx="0" cy="0"/>
+          <a:chOff x="0" y="0"/>
+          <a:chExt cx="0" cy="0"/>
+        </a:xfrm>
+      </p:grpSpPr>
+      <p:sp>
+        <p:nvSpPr>
+          <p:cNvPr id="2" name="Text 0"/>
+          <p:cNvSpPr/>
+          <p:nvPr/>
+        </p:nvSpPr>
+        <p:spPr>
+          <a:xfrm>
+            <a:off x="640080" y="548640"/>
+            <a:ext cx="8229600" cy="274320"/>
+          </a:xfrm>
+          <a:prstGeom prst="rect">
+            <a:avLst/>
+          </a:prstGeom>
+          <a:noFill/>
+          <a:ln/>
+        </p:spPr>
+        <p:txBody>
+          <a:bodyPr wrap="square" lIns="0" tIns="0" rIns="0" bIns="0" rtlCol="0" anchor="ctr"/>
+          <a:lstStyle/>
+          <a:p>
+            <a:pPr algn="l" indent="0" marL="0">
+              <a:buNone/>
+            </a:pPr>
+            <a:r>
+              <a:rPr lang="en-US" sz="1200" b="1" spc="300" kern="0" dirty="0">
+                <a:solidFill>
+                  <a:srgbClr val="9A7A28"/>
+                </a:solidFill>
+                <a:latin typeface="Consolas" pitchFamily="34" charset="0"/>
+                <a:ea typeface="Consolas" pitchFamily="34" charset="-122"/>
+                <a:cs typeface="Consolas" pitchFamily="34" charset="-120"/>
+              </a:rPr>
+              <a:t>MEASURING IMPACT</a:t>
+            </a:r>
+            <a:endParaRPr lang="en-US" sz="1200" dirty="0"/>
+          </a:p>
+        </p:txBody>
+      </p:sp>
+      <p:sp>
+        <p:nvSpPr>
+          <p:cNvPr id="3" name="Text 1"/>
+          <p:cNvSpPr/>
+          <p:nvPr/>
+        </p:nvSpPr>
+        <p:spPr>
+          <a:xfrm>
+            <a:off x="603504" y="868680"/>
+            <a:ext cx="10972800" cy="731520"/>
+          </a:xfrm>
+          <a:prstGeom prst="rect">
+            <a:avLst/>
+          </a:prstGeom>
+          <a:noFill/>
+          <a:ln/>
+        </p:spPr>
+        <p:txBody>
+          <a:bodyPr wrap="square" lIns="0" tIns="0" rIns="0" bIns="0" rtlCol="0" anchor="ctr"/>
+          <a:lstStyle/>
+          <a:p>
+            <a:pPr indent="0" marL="0">
+              <a:buNone/>
+            </a:pPr>
+            <a:r>
+              <a:rPr lang="en-US" sz="3200" b="1" dirty="0">
+                <a:solidFill>
+                  <a:srgbClr val="2B2723"/>
+                </a:solidFill>
+                <a:latin typeface="Bookman Old Style" pitchFamily="34" charset="0"/>
+                <a:ea typeface="Bookman Old Style" pitchFamily="34" charset="-122"/>
+                <a:cs typeface="Bookman Old Style" pitchFamily="34" charset="-120"/>
+              </a:rPr>
+              <a:t>How we'll know it's working</a:t>
+            </a:r>
+            <a:endParaRPr lang="en-US" sz="3200" dirty="0"/>
+          </a:p>
+        </p:txBody>
+      </p:sp>
+      <p:sp>
+        <p:nvSpPr>
+          <p:cNvPr id="4" name="Text 2"/>
+          <p:cNvSpPr/>
+          <p:nvPr/>
+        </p:nvSpPr>
+        <p:spPr>
+          <a:xfrm>
+            <a:off x="640080" y="1691640"/>
+            <a:ext cx="10972800" cy="548640"/>
+          </a:xfrm>
+          <a:prstGeom prst="rect">
+            <a:avLst/>
+          </a:prstGeom>
+          <a:noFill/>
+          <a:ln/>
+        </p:spPr>
+        <p:txBody>
+          <a:bodyPr wrap="square" lIns="0" tIns="0" rIns="0" bIns="0" rtlCol="0" anchor="ctr"/>
+          <a:lstStyle/>
+          <a:p>
+            <a:pPr indent="0" marL="0">
+              <a:buNone/>
+            </a:pPr>
+            <a:r>
+              <a:rPr lang="en-US" sz="1500" dirty="0">
+                <a:solidFill>
+                  <a:srgbClr val="6E675C"/>
+                </a:solidFill>
+                <a:latin typeface="Calibri" pitchFamily="34" charset="0"/>
+                <a:ea typeface="Calibri" pitchFamily="34" charset="-122"/>
+                <a:cs typeface="Calibri" pitchFamily="34" charset="-120"/>
+              </a:rPr>
+              <a:t>Year one is the baseline. Here's what BeHistorical already lets us see — and the outcomes we'll measure against it.</a:t>
+            </a:r>
+            <a:endParaRPr lang="en-US" sz="1500" dirty="0"/>
+          </a:p>
+        </p:txBody>
+      </p:sp>
+      <p:sp>
+        <p:nvSpPr>
+          <p:cNvPr id="5" name="Shape 3"/>
+          <p:cNvSpPr/>
+          <p:nvPr/>
+        </p:nvSpPr>
+        <p:spPr>
+          <a:xfrm>
+            <a:off x="640080" y="2377440"/>
+            <a:ext cx="5394960" cy="2880360"/>
+          </a:xfrm>
+          <a:prstGeom prst="roundRect">
+            <a:avLst>
+              <a:gd name="adj" fmla="val 3810"/>
+            </a:avLst>
+          </a:prstGeom>
+          <a:solidFill>
+            <a:srgbClr val="FCF8F0"/>
+          </a:solidFill>
+          <a:ln w="12700">
+            <a:solidFill>
+              <a:srgbClr val="E4DBC9"/>
+            </a:solidFill>
+            <a:prstDash val="solid"/>
+          </a:ln>
+        </p:spPr>
+      </p:sp>
+      <p:sp>
+        <p:nvSpPr>
+          <p:cNvPr id="6" name="Text 4"/>
+          <p:cNvSpPr/>
+          <p:nvPr/>
+        </p:nvSpPr>
+        <p:spPr>
+          <a:xfrm>
+            <a:off x="960120" y="2651760"/>
+            <a:ext cx="4754880" cy="274320"/>
+          </a:xfrm>
+          <a:prstGeom prst="rect">
+            <a:avLst/>
+          </a:prstGeom>
+          <a:noFill/>
+          <a:ln/>
+        </p:spPr>
+        <p:txBody>
+          <a:bodyPr wrap="square" lIns="0" tIns="0" rIns="0" bIns="0" rtlCol="0" anchor="ctr"/>
+          <a:lstStyle/>
+          <a:p>
+            <a:pPr indent="0" marL="0">
+              <a:buNone/>
+            </a:pPr>
+            <a:r>
+              <a:rPr lang="en-US" sz="1100" b="1" spc="100" kern="0" dirty="0">
+                <a:solidFill>
+                  <a:srgbClr val="3D7A4D"/>
+                </a:solidFill>
+                <a:latin typeface="Consolas" pitchFamily="34" charset="0"/>
+                <a:ea typeface="Consolas" pitchFamily="34" charset="-122"/>
+                <a:cs typeface="Consolas" pitchFamily="34" charset="-120"/>
+              </a:rPr>
+              <a:t>✓ WHAT WE CAN ALREADY SEE</a:t>
+            </a:r>
+            <a:endParaRPr lang="en-US" sz="1100" dirty="0"/>
+          </a:p>
+        </p:txBody>
+      </p:sp>
+      <p:sp>
+        <p:nvSpPr>
+          <p:cNvPr id="7" name="Text 5"/>
+          <p:cNvSpPr/>
+          <p:nvPr/>
+        </p:nvSpPr>
+        <p:spPr>
+          <a:xfrm>
+            <a:off x="960120" y="3090672"/>
+            <a:ext cx="4709160" cy="2011680"/>
+          </a:xfrm>
+          <a:prstGeom prst="rect">
+            <a:avLst/>
+          </a:prstGeom>
+          <a:noFill/>
+          <a:ln/>
+        </p:spPr>
+        <p:txBody>
+          <a:bodyPr wrap="square" lIns="0" tIns="0" rIns="0" bIns="0" rtlCol="0" anchor="t"/>
+          <a:lstStyle/>
+          <a:p>
+            <a:pPr marL="177800" indent="-177800">
+              <a:spcAft>
+                <a:spcPts val="1000"/>
+              </a:spcAft>
+              <a:buSzPct val="100000"/>
+              <a:buChar char="•"/>
+            </a:pPr>
+            <a:r>
+              <a:rPr lang="en-US" sz="1350" dirty="0">
+                <a:solidFill>
+                  <a:srgbClr val="6E675C"/>
+                </a:solidFill>
+                <a:latin typeface="Calibri" pitchFamily="34" charset="0"/>
+                <a:ea typeface="Calibri" pitchFamily="34" charset="-122"/>
+                <a:cs typeface="Calibri" pitchFamily="34" charset="-120"/>
+              </a:rPr>
+              <a:t>Participation &amp; completion, per lesson and module</a:t>
+            </a:r>
+            <a:endParaRPr lang="en-US" sz="1350" dirty="0"/>
+          </a:p>
+          <a:p>
+            <a:pPr marL="177800" indent="-177800">
+              <a:spcAft>
+                <a:spcPts val="1000"/>
+              </a:spcAft>
+              <a:buSzPct val="100000"/>
+              <a:buChar char="•"/>
+            </a:pPr>
+            <a:r>
+              <a:rPr lang="en-US" sz="1350" dirty="0">
+                <a:solidFill>
+                  <a:srgbClr val="6E675C"/>
+                </a:solidFill>
+                <a:latin typeface="Calibri" pitchFamily="34" charset="0"/>
+                <a:ea typeface="Calibri" pitchFamily="34" charset="-122"/>
+                <a:cs typeface="Calibri" pitchFamily="34" charset="-120"/>
+              </a:rPr>
+              <a:t>Confidence trends across a unit (1–5 self-ratings)</a:t>
+            </a:r>
+            <a:endParaRPr lang="en-US" sz="1350" dirty="0"/>
+          </a:p>
+          <a:p>
+            <a:pPr marL="177800" indent="-177800">
+              <a:spcAft>
+                <a:spcPts val="1000"/>
+              </a:spcAft>
+              <a:buSzPct val="100000"/>
+              <a:buChar char="•"/>
+            </a:pPr>
+            <a:r>
+              <a:rPr lang="en-US" sz="1350" dirty="0">
+                <a:solidFill>
+                  <a:srgbClr val="6E675C"/>
+                </a:solidFill>
+                <a:latin typeface="Calibri" pitchFamily="34" charset="0"/>
+                <a:ea typeface="Calibri" pitchFamily="34" charset="-122"/>
+                <a:cs typeface="Calibri" pitchFamily="34" charset="-120"/>
+              </a:rPr>
+              <a:t>AI-coaching engagement — coaching rounds per student</a:t>
+            </a:r>
+            <a:endParaRPr lang="en-US" sz="1350" dirty="0"/>
+          </a:p>
+          <a:p>
+            <a:pPr marL="177800" indent="-177800">
+              <a:spcAft>
+                <a:spcPts val="1000"/>
+              </a:spcAft>
+              <a:buSzPct val="100000"/>
+              <a:buChar char="•"/>
+            </a:pPr>
+            <a:r>
+              <a:rPr lang="en-US" sz="1350" dirty="0">
+                <a:solidFill>
+                  <a:srgbClr val="6E675C"/>
+                </a:solidFill>
+                <a:latin typeface="Calibri" pitchFamily="34" charset="0"/>
+                <a:ea typeface="Calibri" pitchFamily="34" charset="-122"/>
+                <a:cs typeface="Calibri" pitchFamily="34" charset="-120"/>
+              </a:rPr>
+              <a:t>Response-quality signals — evidence use &amp; reasoning language</a:t>
+            </a:r>
+            <a:endParaRPr lang="en-US" sz="1350" dirty="0"/>
+          </a:p>
+        </p:txBody>
+      </p:sp>
+      <p:sp>
+        <p:nvSpPr>
+          <p:cNvPr id="8" name="Shape 6"/>
+          <p:cNvSpPr/>
+          <p:nvPr/>
+        </p:nvSpPr>
+        <p:spPr>
+          <a:xfrm>
+            <a:off x="6126480" y="2377440"/>
+            <a:ext cx="5394960" cy="2880360"/>
+          </a:xfrm>
+          <a:prstGeom prst="roundRect">
+            <a:avLst>
+              <a:gd name="adj" fmla="val 3810"/>
+            </a:avLst>
+          </a:prstGeom>
+          <a:solidFill>
+            <a:srgbClr val="FCF8F0"/>
+          </a:solidFill>
+          <a:ln w="12700">
+            <a:solidFill>
+              <a:srgbClr val="E4DBC9"/>
+            </a:solidFill>
+            <a:prstDash val="solid"/>
+          </a:ln>
+        </p:spPr>
+      </p:sp>
+      <p:sp>
+        <p:nvSpPr>
+          <p:cNvPr id="9" name="Text 7"/>
+          <p:cNvSpPr/>
+          <p:nvPr/>
+        </p:nvSpPr>
+        <p:spPr>
+          <a:xfrm>
+            <a:off x="6446520" y="2651760"/>
+            <a:ext cx="4754880" cy="274320"/>
+          </a:xfrm>
+          <a:prstGeom prst="rect">
+            <a:avLst/>
+          </a:prstGeom>
+          <a:noFill/>
+          <a:ln/>
+        </p:spPr>
+        <p:txBody>
+          <a:bodyPr wrap="square" lIns="0" tIns="0" rIns="0" bIns="0" rtlCol="0" anchor="ctr"/>
+          <a:lstStyle/>
+          <a:p>
+            <a:pPr indent="0" marL="0">
+              <a:buNone/>
+            </a:pPr>
+            <a:r>
+              <a:rPr lang="en-US" sz="1100" b="1" spc="100" kern="0" dirty="0">
+                <a:solidFill>
+                  <a:srgbClr val="9A7A28"/>
+                </a:solidFill>
+                <a:latin typeface="Consolas" pitchFamily="34" charset="0"/>
+                <a:ea typeface="Consolas" pitchFamily="34" charset="-122"/>
+                <a:cs typeface="Consolas" pitchFamily="34" charset="-120"/>
+              </a:rPr>
+              <a:t>◎ WHAT WE'LL PROVE</a:t>
+            </a:r>
+            <a:endParaRPr lang="en-US" sz="1100" dirty="0"/>
+          </a:p>
+        </p:txBody>
+      </p:sp>
+      <p:sp>
+        <p:nvSpPr>
+          <p:cNvPr id="10" name="Text 8"/>
+          <p:cNvSpPr/>
+          <p:nvPr/>
+        </p:nvSpPr>
+        <p:spPr>
+          <a:xfrm>
+            <a:off x="6446520" y="3090672"/>
+            <a:ext cx="4709160" cy="2011680"/>
+          </a:xfrm>
+          <a:prstGeom prst="rect">
+            <a:avLst/>
+          </a:prstGeom>
+          <a:noFill/>
+          <a:ln/>
+        </p:spPr>
+        <p:txBody>
+          <a:bodyPr wrap="square" lIns="0" tIns="0" rIns="0" bIns="0" rtlCol="0" anchor="t"/>
+          <a:lstStyle/>
+          <a:p>
+            <a:pPr marL="177800" indent="-177800">
+              <a:spcAft>
+                <a:spcPts val="1000"/>
+              </a:spcAft>
+              <a:buSzPct val="100000"/>
+              <a:buChar char="•"/>
+            </a:pPr>
+            <a:r>
+              <a:rPr lang="en-US" sz="1350" dirty="0">
+                <a:solidFill>
+                  <a:srgbClr val="6E675C"/>
+                </a:solidFill>
+                <a:latin typeface="Calibri" pitchFamily="34" charset="0"/>
+                <a:ea typeface="Calibri" pitchFamily="34" charset="-122"/>
+                <a:cs typeface="Calibri" pitchFamily="34" charset="-120"/>
+              </a:rPr>
+              <a:t>AP exam 3+ rate vs. prior years</a:t>
+            </a:r>
+            <a:endParaRPr lang="en-US" sz="1350" dirty="0"/>
+          </a:p>
+          <a:p>
+            <a:pPr marL="177800" indent="-177800">
+              <a:spcAft>
+                <a:spcPts val="1000"/>
+              </a:spcAft>
+              <a:buSzPct val="100000"/>
+              <a:buChar char="•"/>
+            </a:pPr>
+            <a:r>
+              <a:rPr lang="en-US" sz="1350" dirty="0">
+                <a:solidFill>
+                  <a:srgbClr val="6E675C"/>
+                </a:solidFill>
+                <a:latin typeface="Calibri" pitchFamily="34" charset="0"/>
+                <a:ea typeface="Calibri" pitchFamily="34" charset="-122"/>
+                <a:cs typeface="Calibri" pitchFamily="34" charset="-120"/>
+              </a:rPr>
+              <a:t>SAQ / DBQ rubric growth, pre → post</a:t>
+            </a:r>
+            <a:endParaRPr lang="en-US" sz="1350" dirty="0"/>
+          </a:p>
+          <a:p>
+            <a:pPr marL="177800" indent="-177800">
+              <a:spcAft>
+                <a:spcPts val="1000"/>
+              </a:spcAft>
+              <a:buSzPct val="100000"/>
+              <a:buChar char="•"/>
+            </a:pPr>
+            <a:r>
+              <a:rPr lang="en-US" sz="1350" dirty="0">
+                <a:solidFill>
+                  <a:srgbClr val="6E675C"/>
+                </a:solidFill>
+                <a:latin typeface="Calibri" pitchFamily="34" charset="0"/>
+                <a:ea typeface="Calibri" pitchFamily="34" charset="-122"/>
+                <a:cs typeface="Calibri" pitchFamily="34" charset="-120"/>
+              </a:rPr>
+              <a:t>MCQ mastery by Key Concept</a:t>
+            </a:r>
+            <a:endParaRPr lang="en-US" sz="1350" dirty="0"/>
+          </a:p>
+          <a:p>
+            <a:pPr marL="177800" indent="-177800">
+              <a:spcAft>
+                <a:spcPts val="1000"/>
+              </a:spcAft>
+              <a:buSzPct val="100000"/>
+              <a:buChar char="•"/>
+            </a:pPr>
+            <a:r>
+              <a:rPr lang="en-US" sz="1350" dirty="0">
+                <a:solidFill>
+                  <a:srgbClr val="6E675C"/>
+                </a:solidFill>
+                <a:latin typeface="Calibri" pitchFamily="34" charset="0"/>
+                <a:ea typeface="Calibri" pitchFamily="34" charset="-122"/>
+                <a:cs typeface="Calibri" pitchFamily="34" charset="-120"/>
+              </a:rPr>
+              <a:t>Family engagement — Dispatch open &amp; click rates</a:t>
+            </a:r>
+            <a:endParaRPr lang="en-US" sz="1350" dirty="0"/>
+          </a:p>
+        </p:txBody>
+      </p:sp>
+      <p:sp>
+        <p:nvSpPr>
+          <p:cNvPr id="11" name="Text 9"/>
+          <p:cNvSpPr/>
+          <p:nvPr/>
+        </p:nvSpPr>
+        <p:spPr>
+          <a:xfrm>
+            <a:off x="640080" y="5486400"/>
+            <a:ext cx="10972800" cy="365760"/>
+          </a:xfrm>
+          <a:prstGeom prst="rect">
+            <a:avLst/>
+          </a:prstGeom>
+          <a:noFill/>
+          <a:ln/>
+        </p:spPr>
+        <p:txBody>
+          <a:bodyPr wrap="square" lIns="0" tIns="0" rIns="0" bIns="0" rtlCol="0" anchor="ctr"/>
+          <a:lstStyle/>
+          <a:p>
+            <a:pPr indent="0" marL="0">
+              <a:buNone/>
+            </a:pPr>
+            <a:r>
+              <a:rPr lang="en-US" sz="1100" dirty="0">
+                <a:solidFill>
+                  <a:srgbClr val="6E675C"/>
+                </a:solidFill>
+                <a:latin typeface="Consolas" pitchFamily="34" charset="0"/>
+                <a:ea typeface="Consolas" pitchFamily="34" charset="-122"/>
+                <a:cs typeface="Consolas" pitchFamily="34" charset="-120"/>
+              </a:rPr>
+              <a:t>Method: pre/post on CED-aligned items · section-to-section comparison · tracked in the Teacher Hub · baseline year 2026–27</a:t>
+            </a:r>
+            <a:endParaRPr lang="en-US" sz="1100" dirty="0"/>
+          </a:p>
+        </p:txBody>
+      </p:sp>
+      <p:sp>
+        <p:nvSpPr>
+          <p:cNvPr id="12" name="Text 10"/>
+          <p:cNvSpPr/>
+          <p:nvPr/>
+        </p:nvSpPr>
+        <p:spPr>
+          <a:xfrm>
+            <a:off x="502920" y="6400800"/>
+            <a:ext cx="7315200" cy="274320"/>
+          </a:xfrm>
+          <a:prstGeom prst="rect">
+            <a:avLst/>
+          </a:prstGeom>
+          <a:noFill/>
+          <a:ln/>
+        </p:spPr>
+        <p:txBody>
+          <a:bodyPr wrap="square" lIns="0" tIns="0" rIns="0" bIns="0" rtlCol="0" anchor="ctr"/>
+          <a:lstStyle/>
+          <a:p>
+            <a:pPr algn="l" indent="0" marL="0">
+              <a:buNone/>
+            </a:pPr>
+            <a:r>
+              <a:rPr lang="en-US" sz="1000" b="1" dirty="0">
+                <a:solidFill>
+                  <a:srgbClr val="C9A24B"/>
+                </a:solidFill>
+                <a:latin typeface="Calibri" pitchFamily="34" charset="0"/>
+                <a:ea typeface="Calibri" pitchFamily="34" charset="-122"/>
+                <a:cs typeface="Calibri" pitchFamily="34" charset="-120"/>
+              </a:rPr>
+              <a:t>AndersonLogic AI</a:t>
+            </a:r>
+            <a:pPr algn="l" indent="0" marL="0">
+              <a:buNone/>
+            </a:pPr>
+            <a:r>
+              <a:rPr lang="en-US" sz="1000" dirty="0">
+                <a:solidFill>
+                  <a:srgbClr val="6E675C"/>
+                </a:solidFill>
+                <a:latin typeface="Calibri" pitchFamily="34" charset="0"/>
+                <a:ea typeface="Calibri" pitchFamily="34" charset="-122"/>
+                <a:cs typeface="Calibri" pitchFamily="34" charset="-120"/>
+              </a:rPr>
+              <a:t>   ·   BeHistorical</a:t>
+            </a:r>
+            <a:endParaRPr lang="en-US" sz="1000" dirty="0"/>
+          </a:p>
+        </p:txBody>
+      </p:sp>
+      <p:sp>
+        <p:nvSpPr>
+          <p:cNvPr id="13" name="Text 11"/>
+          <p:cNvSpPr/>
+          <p:nvPr/>
+        </p:nvSpPr>
+        <p:spPr>
+          <a:xfrm>
+            <a:off x="10607040" y="6355080"/>
+            <a:ext cx="1097280" cy="320040"/>
+          </a:xfrm>
+          <a:prstGeom prst="rect">
+            <a:avLst/>
+          </a:prstGeom>
+          <a:noFill/>
+          <a:ln/>
+        </p:spPr>
+        <p:txBody>
+          <a:bodyPr wrap="square" lIns="0" tIns="0" rIns="0" bIns="0" rtlCol="0" anchor="ctr"/>
+          <a:lstStyle/>
+          <a:p>
+            <a:pPr algn="r" indent="0" marL="0">
+              <a:buNone/>
+            </a:pPr>
+            <a:r>
+              <a:rPr lang="en-US" sz="1100" b="1" dirty="0">
+                <a:solidFill>
+                  <a:srgbClr val="6E675C"/>
+                </a:solidFill>
+                <a:latin typeface="Consolas" pitchFamily="34" charset="0"/>
+                <a:ea typeface="Consolas" pitchFamily="34" charset="-122"/>
+                <a:cs typeface="Consolas" pitchFamily="34" charset="-120"/>
+              </a:rPr>
+              <a:t>16 / 18</a:t>
+            </a:r>
+            <a:endParaRPr lang="en-US" sz="1100" dirty="0"/>
+          </a:p>
+        </p:txBody>
+      </p:sp>
+    </p:spTree>
+  </p:cSld>
+  <p:clrMapOvr>
+    <a:masterClrMapping/>
+  </p:clrMapOvr>
+</p:sld>
+</file>
+
+<file path=ppt/slides/slide18.xml><?xml version="1.0" encoding="utf-8"?>
+<p:sld xmlns:a="http://schemas.openxmlformats.org/drawingml/2006/main" xmlns:r="http://schemas.openxmlformats.org/officeDocument/2006/relationships" xmlns:p="http://schemas.openxmlformats.org/presentationml/2006/main">
+  <p:cSld name="Slide 18">
     <p:bg>
       <p:bgPr>
         <a:solidFill>
@@ -9268,7 +9981,7 @@
                 <a:ea typeface="Consolas" pitchFamily="34" charset="-122"/>
                 <a:cs typeface="Consolas" pitchFamily="34" charset="-120"/>
               </a:rPr>
-              <a:t>17 / 17</a:t>
+              <a:t>18 / 18</a:t>
             </a:r>
             <a:endParaRPr lang="en-US" sz="1100" dirty="0"/>
           </a:p>
@@ -9920,7 +10633,7 @@
                 <a:ea typeface="Consolas" pitchFamily="34" charset="-122"/>
                 <a:cs typeface="Consolas" pitchFamily="34" charset="-120"/>
               </a:rPr>
-              <a:t>02 / 17</a:t>
+              <a:t>02 / 18</a:t>
             </a:r>
             <a:endParaRPr lang="en-US" sz="1100" dirty="0"/>
           </a:p>
@@ -10776,7 +11489,7 @@
                 <a:ea typeface="Consolas" pitchFamily="34" charset="-122"/>
                 <a:cs typeface="Consolas" pitchFamily="34" charset="-120"/>
               </a:rPr>
-              <a:t>03 / 17</a:t>
+              <a:t>03 / 18</a:t>
             </a:r>
             <a:endParaRPr lang="en-US" sz="1100" dirty="0"/>
           </a:p>
@@ -11470,7 +12183,7 @@
                 <a:ea typeface="Consolas" pitchFamily="34" charset="-122"/>
                 <a:cs typeface="Consolas" pitchFamily="34" charset="-120"/>
               </a:rPr>
-              <a:t>04 / 17</a:t>
+              <a:t>04 / 18</a:t>
             </a:r>
             <a:endParaRPr lang="en-US" sz="1100" dirty="0"/>
           </a:p>
@@ -12356,7 +13069,7 @@
                 <a:ea typeface="Consolas" pitchFamily="34" charset="-122"/>
                 <a:cs typeface="Consolas" pitchFamily="34" charset="-120"/>
               </a:rPr>
-              <a:t>05 / 17</a:t>
+              <a:t>05 / 18</a:t>
             </a:r>
             <a:endParaRPr lang="en-US" sz="1100" dirty="0"/>
           </a:p>
@@ -13598,7 +14311,7 @@
                 <a:ea typeface="Consolas" pitchFamily="34" charset="-122"/>
                 <a:cs typeface="Consolas" pitchFamily="34" charset="-120"/>
               </a:rPr>
-              <a:t>06 / 17</a:t>
+              <a:t>06 / 18</a:t>
             </a:r>
             <a:endParaRPr lang="en-US" sz="1100" dirty="0"/>
           </a:p>
@@ -14927,7 +15640,7 @@
                 <a:ea typeface="Consolas" pitchFamily="34" charset="-122"/>
                 <a:cs typeface="Consolas" pitchFamily="34" charset="-120"/>
               </a:rPr>
-              <a:t>07 / 17</a:t>
+              <a:t>07 / 18</a:t>
             </a:r>
             <a:endParaRPr lang="en-US" sz="1100" dirty="0"/>
           </a:p>
@@ -15723,7 +16436,7 @@
                 <a:ea typeface="Consolas" pitchFamily="34" charset="-122"/>
                 <a:cs typeface="Consolas" pitchFamily="34" charset="-120"/>
               </a:rPr>
-              <a:t>08 / 17</a:t>
+              <a:t>08 / 18</a:t>
             </a:r>
             <a:endParaRPr lang="en-US" sz="1100" dirty="0"/>
           </a:p>
@@ -16519,7 +17232,7 @@
                 <a:ea typeface="Consolas" pitchFamily="34" charset="-122"/>
                 <a:cs typeface="Consolas" pitchFamily="34" charset="-120"/>
               </a:rPr>
-              <a:t>09 / 17</a:t>
+              <a:t>09 / 18</a:t>
             </a:r>
             <a:endParaRPr lang="en-US" sz="1100" dirty="0"/>
           </a:p>

</xml_diff>